<commit_message>
Update presentation and add progress eval
</commit_message>
<xml_diff>
--- a/docs/milestone_3/Milestone_3_Presentation.pptx
+++ b/docs/milestone_3/Milestone_3_Presentation.pptx
@@ -12239,7 +12239,15 @@
             </a:pPr>
             <a:r>
               <a:rPr lang="en"/>
-              <a:t>We have implemented basic backend integration with our python api and are laying the foundation for integration with the NIST 800-90b and open quantum safe libraries </a:t>
+              <a:t>We have implemented basic backend integration with our python api and are laying the foundation for integration with the NIST </a:t>
+            </a:r>
+            <a:r>
+              <a:rPr lang="en"/>
+              <a:t>800-90B</a:t>
+            </a:r>
+            <a:r>
+              <a:rPr lang="en"/>
+              <a:t> and open quantum safe libraries </a:t>
             </a:r>
             <a:endParaRPr/>
           </a:p>
@@ -12372,7 +12380,7 @@
             </a:r>
             <a:r>
               <a:rPr lang="en"/>
-              <a:t>st wrappers for the nist 800-90b entropy testing suite </a:t>
+              <a:t>st wrappers for the nist 800-90B entropy testing suite </a:t>
             </a:r>
             <a:endParaRPr/>
           </a:p>
@@ -13135,7 +13143,7 @@
             <a:tbl>
               <a:tblPr>
                 <a:noFill/>
-                <a:tableStyleId>{B0F61F51-C208-474C-8294-486FD4EF4A6F}</a:tableStyleId>
+                <a:tableStyleId>{0AC21148-4255-4F54-BE0F-748718AC2667}</a:tableStyleId>
               </a:tblPr>
               <a:tblGrid>
                 <a:gridCol w="2053200"/>
@@ -13951,7 +13959,7 @@
                           <a:cs typeface="Times New Roman"/>
                           <a:sym typeface="Times New Roman"/>
                         </a:rPr>
-                        <a:t>Integrate the data fetchers into the api and the database</a:t>
+                        <a:t>Integrate the data fetchers into the API and the database</a:t>
                       </a:r>
                       <a:endParaRPr sz="1200">
                         <a:latin typeface="Times New Roman"/>
@@ -15356,7 +15364,7 @@
             <a:tbl>
               <a:tblPr>
                 <a:noFill/>
-                <a:tableStyleId>{B0F61F51-C208-474C-8294-486FD4EF4A6F}</a:tableStyleId>
+                <a:tableStyleId>{0AC21148-4255-4F54-BE0F-748718AC2667}</a:tableStyleId>
               </a:tblPr>
               <a:tblGrid>
                 <a:gridCol w="1495525"/>
@@ -16232,7 +16240,7 @@
                           <a:cs typeface="Times New Roman"/>
                           <a:sym typeface="Times New Roman"/>
                         </a:rPr>
-                        <a:t>3. Entropy analysis</a:t>
+                        <a:t>3. Entropy analysis and maximization</a:t>
                       </a:r>
                       <a:endParaRPr sz="1200">
                         <a:latin typeface="Times New Roman"/>
@@ -16270,7 +16278,7 @@
                       <a:headEnd len="sm" w="sm" type="none"/>
                       <a:tailEnd len="sm" w="sm" type="none"/>
                     </a:lnT>
-                    <a:lnB cap="flat" cmpd="sng" w="9525">
+                    <a:lnB cap="flat" cmpd="sng" w="12700">
                       <a:solidFill>
                         <a:srgbClr val="000000"/>
                       </a:solidFill>
@@ -16302,7 +16310,25 @@
                           <a:cs typeface="Times New Roman"/>
                           <a:sym typeface="Times New Roman"/>
                         </a:rPr>
-                        <a:t>Will gather 10^6 data points per data set and run NIST 800-90b entropy testing suite </a:t>
+                        <a:t>Will gather 10^6 data points per data set and run NIST </a:t>
+                      </a:r>
+                      <a:r>
+                        <a:rPr lang="en" sz="1200">
+                          <a:latin typeface="Times New Roman"/>
+                          <a:ea typeface="Times New Roman"/>
+                          <a:cs typeface="Times New Roman"/>
+                          <a:sym typeface="Times New Roman"/>
+                        </a:rPr>
+                        <a:t>800-90B</a:t>
+                      </a:r>
+                      <a:r>
+                        <a:rPr lang="en" sz="1200">
+                          <a:latin typeface="Times New Roman"/>
+                          <a:ea typeface="Times New Roman"/>
+                          <a:cs typeface="Times New Roman"/>
+                          <a:sym typeface="Times New Roman"/>
+                        </a:rPr>
+                        <a:t> entropy testing suite </a:t>
                       </a:r>
                       <a:endParaRPr sz="1200">
                         <a:latin typeface="Times New Roman"/>
@@ -16525,7 +16551,7 @@
                     </a:p>
                   </a:txBody>
                   <a:tcPr marT="63500" marB="63500" marR="63500" marL="63500">
-                    <a:lnL cap="flat" cmpd="sng" w="9525">
+                    <a:lnL cap="flat" cmpd="sng" w="12700">
                       <a:solidFill>
                         <a:srgbClr val="000000"/>
                       </a:solidFill>
@@ -16534,7 +16560,7 @@
                       <a:headEnd len="sm" w="sm" type="none"/>
                       <a:tailEnd len="sm" w="sm" type="none"/>
                     </a:lnL>
-                    <a:lnR cap="flat" cmpd="sng" w="9525">
+                    <a:lnR cap="flat" cmpd="sng" w="12700">
                       <a:solidFill>
                         <a:srgbClr val="000000"/>
                       </a:solidFill>
@@ -16543,7 +16569,7 @@
                       <a:headEnd len="sm" w="sm" type="none"/>
                       <a:tailEnd len="sm" w="sm" type="none"/>
                     </a:lnR>
-                    <a:lnT cap="flat" cmpd="sng" w="9525">
+                    <a:lnT cap="flat" cmpd="sng" w="12700">
                       <a:solidFill>
                         <a:srgbClr val="000000"/>
                       </a:solidFill>
@@ -16552,7 +16578,7 @@
                       <a:headEnd len="sm" w="sm" type="none"/>
                       <a:tailEnd len="sm" w="sm" type="none"/>
                     </a:lnT>
-                    <a:lnB cap="flat" cmpd="sng" w="9525">
+                    <a:lnB cap="flat" cmpd="sng" w="12700">
                       <a:solidFill>
                         <a:srgbClr val="000000"/>
                       </a:solidFill>
@@ -16595,7 +16621,7 @@
                     </a:p>
                   </a:txBody>
                   <a:tcPr marT="63500" marB="63500" marR="63500" marL="63500">
-                    <a:lnL cap="flat" cmpd="sng" w="9525">
+                    <a:lnL cap="flat" cmpd="sng" w="12700">
                       <a:solidFill>
                         <a:srgbClr val="000000"/>
                       </a:solidFill>
@@ -16795,9 +16821,9 @@
 </file>
 
 <file path=ppt/theme/theme1.xml><?xml version="1.0" encoding="utf-8"?>
-<a:theme xmlns:a="http://schemas.openxmlformats.org/drawingml/2006/main" xmlns:r="http://schemas.openxmlformats.org/officeDocument/2006/relationships" name="Luxe">
+<a:theme xmlns:a="http://schemas.openxmlformats.org/drawingml/2006/main" xmlns:r="http://schemas.openxmlformats.org/officeDocument/2006/relationships" name="Simple Light">
   <a:themeElements>
-    <a:clrScheme name="Luxe">
+    <a:clrScheme name="Simple Light">
       <a:dk1>
         <a:srgbClr val="000000"/>
       </a:dk1>
@@ -16805,34 +16831,34 @@
         <a:srgbClr val="FFFFFF"/>
       </a:lt1>
       <a:dk2>
-        <a:srgbClr val="B7B7B7"/>
+        <a:srgbClr val="595959"/>
       </a:dk2>
       <a:lt2>
-        <a:srgbClr val="CCA677"/>
+        <a:srgbClr val="EEEEEE"/>
       </a:lt2>
       <a:accent1>
-        <a:srgbClr val="5D4037"/>
+        <a:srgbClr val="4285F4"/>
       </a:accent1>
       <a:accent2>
-        <a:srgbClr val="455A64"/>
+        <a:srgbClr val="212121"/>
       </a:accent2>
       <a:accent3>
-        <a:srgbClr val="57BB8A"/>
+        <a:srgbClr val="78909C"/>
       </a:accent3>
       <a:accent4>
-        <a:srgbClr val="78909C"/>
+        <a:srgbClr val="FFAB40"/>
       </a:accent4>
       <a:accent5>
-        <a:srgbClr val="607D8B"/>
+        <a:srgbClr val="0097A7"/>
       </a:accent5>
       <a:accent6>
-        <a:srgbClr val="DCE755"/>
+        <a:srgbClr val="EEFF41"/>
       </a:accent6>
       <a:hlink>
-        <a:srgbClr val="607D8B"/>
+        <a:srgbClr val="0097A7"/>
       </a:hlink>
       <a:folHlink>
-        <a:srgbClr val="607D8B"/>
+        <a:srgbClr val="0097A7"/>
       </a:folHlink>
     </a:clrScheme>
     <a:fontScheme name="Office">
@@ -17074,9 +17100,9 @@
 </file>
 
 <file path=ppt/theme/theme2.xml><?xml version="1.0" encoding="utf-8"?>
-<a:theme xmlns:a="http://schemas.openxmlformats.org/drawingml/2006/main" xmlns:r="http://schemas.openxmlformats.org/officeDocument/2006/relationships" name="Simple Light">
+<a:theme xmlns:a="http://schemas.openxmlformats.org/drawingml/2006/main" xmlns:r="http://schemas.openxmlformats.org/officeDocument/2006/relationships" name="Luxe">
   <a:themeElements>
-    <a:clrScheme name="Simple Light">
+    <a:clrScheme name="Luxe">
       <a:dk1>
         <a:srgbClr val="000000"/>
       </a:dk1>
@@ -17084,34 +17110,34 @@
         <a:srgbClr val="FFFFFF"/>
       </a:lt1>
       <a:dk2>
-        <a:srgbClr val="595959"/>
+        <a:srgbClr val="B7B7B7"/>
       </a:dk2>
       <a:lt2>
-        <a:srgbClr val="EEEEEE"/>
+        <a:srgbClr val="CCA677"/>
       </a:lt2>
       <a:accent1>
-        <a:srgbClr val="4285F4"/>
+        <a:srgbClr val="5D4037"/>
       </a:accent1>
       <a:accent2>
-        <a:srgbClr val="212121"/>
+        <a:srgbClr val="455A64"/>
       </a:accent2>
       <a:accent3>
-        <a:srgbClr val="78909C"/>
+        <a:srgbClr val="57BB8A"/>
       </a:accent3>
       <a:accent4>
-        <a:srgbClr val="FFAB40"/>
+        <a:srgbClr val="78909C"/>
       </a:accent4>
       <a:accent5>
-        <a:srgbClr val="0097A7"/>
+        <a:srgbClr val="607D8B"/>
       </a:accent5>
       <a:accent6>
-        <a:srgbClr val="EEFF41"/>
+        <a:srgbClr val="DCE755"/>
       </a:accent6>
       <a:hlink>
-        <a:srgbClr val="0097A7"/>
+        <a:srgbClr val="607D8B"/>
       </a:hlink>
       <a:folHlink>
-        <a:srgbClr val="0097A7"/>
+        <a:srgbClr val="607D8B"/>
       </a:folHlink>
     </a:clrScheme>
     <a:fontScheme name="Office">

</xml_diff>